<commit_message>
tokamak vertical plots added
</commit_message>
<xml_diff>
--- a/Figures/fig_blankets.pptx
+++ b/Figures/fig_blankets.pptx
@@ -2,12 +2,12 @@
 <file path=ppt/presentation.xml><?xml version="1.0" encoding="utf-8"?>
 <p:presentation xmlns:a="http://schemas.openxmlformats.org/drawingml/2006/main" xmlns:r="http://schemas.openxmlformats.org/officeDocument/2006/relationships" xmlns:p="http://schemas.openxmlformats.org/presentationml/2006/main" saveSubsetFonts="1">
   <p:sldMasterIdLst>
-    <p:sldMasterId id="2147483744" r:id="rId1"/>
+    <p:sldMasterId id="2147483780" r:id="rId1"/>
   </p:sldMasterIdLst>
   <p:sldIdLst>
     <p:sldId id="256" r:id="rId2"/>
   </p:sldIdLst>
-  <p:sldSz cx="6858000" cy="2743200"/>
+  <p:sldSz cx="6858000" cy="2378075"/>
   <p:notesSz cx="6858000" cy="9144000"/>
   <p:defaultTextStyle>
     <a:defPPr>
@@ -141,15 +141,15 @@
         </p:nvSpPr>
         <p:spPr>
           <a:xfrm>
-            <a:off x="857250" y="448945"/>
-            <a:ext cx="5143500" cy="955040"/>
+            <a:off x="857250" y="389190"/>
+            <a:ext cx="5143500" cy="827922"/>
           </a:xfrm>
         </p:spPr>
         <p:txBody>
           <a:bodyPr anchor="b"/>
           <a:lstStyle>
             <a:lvl1pPr algn="ctr">
-              <a:defRPr sz="2400"/>
+              <a:defRPr sz="2081"/>
             </a:lvl1pPr>
           </a:lstStyle>
           <a:p>
@@ -173,8 +173,8 @@
         </p:nvSpPr>
         <p:spPr>
           <a:xfrm>
-            <a:off x="857250" y="1440815"/>
-            <a:ext cx="5143500" cy="662305"/>
+            <a:off x="857250" y="1249040"/>
+            <a:ext cx="5143500" cy="574151"/>
           </a:xfrm>
         </p:spPr>
         <p:txBody>
@@ -182,39 +182,39 @@
           <a:lstStyle>
             <a:lvl1pPr marL="0" indent="0" algn="ctr">
               <a:buNone/>
-              <a:defRPr sz="960"/>
+              <a:defRPr sz="832"/>
             </a:lvl1pPr>
-            <a:lvl2pPr marL="182880" indent="0" algn="ctr">
+            <a:lvl2pPr marL="158557" indent="0" algn="ctr">
               <a:buNone/>
-              <a:defRPr sz="800"/>
+              <a:defRPr sz="694"/>
             </a:lvl2pPr>
-            <a:lvl3pPr marL="365760" indent="0" algn="ctr">
+            <a:lvl3pPr marL="317114" indent="0" algn="ctr">
               <a:buNone/>
-              <a:defRPr sz="720"/>
+              <a:defRPr sz="624"/>
             </a:lvl3pPr>
-            <a:lvl4pPr marL="548640" indent="0" algn="ctr">
+            <a:lvl4pPr marL="475671" indent="0" algn="ctr">
               <a:buNone/>
-              <a:defRPr sz="640"/>
+              <a:defRPr sz="555"/>
             </a:lvl4pPr>
-            <a:lvl5pPr marL="731520" indent="0" algn="ctr">
+            <a:lvl5pPr marL="634228" indent="0" algn="ctr">
               <a:buNone/>
-              <a:defRPr sz="640"/>
+              <a:defRPr sz="555"/>
             </a:lvl5pPr>
-            <a:lvl6pPr marL="914400" indent="0" algn="ctr">
+            <a:lvl6pPr marL="792785" indent="0" algn="ctr">
               <a:buNone/>
-              <a:defRPr sz="640"/>
+              <a:defRPr sz="555"/>
             </a:lvl6pPr>
-            <a:lvl7pPr marL="1097280" indent="0" algn="ctr">
+            <a:lvl7pPr marL="951342" indent="0" algn="ctr">
               <a:buNone/>
-              <a:defRPr sz="640"/>
+              <a:defRPr sz="555"/>
             </a:lvl7pPr>
-            <a:lvl8pPr marL="1280160" indent="0" algn="ctr">
+            <a:lvl8pPr marL="1109899" indent="0" algn="ctr">
               <a:buNone/>
-              <a:defRPr sz="640"/>
+              <a:defRPr sz="555"/>
             </a:lvl8pPr>
-            <a:lvl9pPr marL="1463040" indent="0" algn="ctr">
+            <a:lvl9pPr marL="1268456" indent="0" algn="ctr">
               <a:buNone/>
-              <a:defRPr sz="640"/>
+              <a:defRPr sz="555"/>
             </a:lvl9pPr>
           </a:lstStyle>
           <a:p>
@@ -243,7 +243,7 @@
           <a:p>
             <a:fld id="{C64808BA-7FDF-40FB-8D34-8FB57E054EF6}" type="datetimeFigureOut">
               <a:rPr lang="en-US" smtClean="0"/>
-              <a:t>05/20/2026</a:t>
+              <a:t>6/17/26</a:t>
             </a:fld>
             <a:endParaRPr lang="en-US"/>
           </a:p>
@@ -294,7 +294,7 @@
     </p:spTree>
     <p:extLst>
       <p:ext uri="{BB962C8B-B14F-4D97-AF65-F5344CB8AC3E}">
-        <p14:creationId xmlns:p14="http://schemas.microsoft.com/office/powerpoint/2010/main" val="237138977"/>
+        <p14:creationId xmlns:p14="http://schemas.microsoft.com/office/powerpoint/2010/main" val="407286775"/>
       </p:ext>
     </p:extLst>
   </p:cSld>
@@ -413,7 +413,7 @@
           <a:p>
             <a:fld id="{C64808BA-7FDF-40FB-8D34-8FB57E054EF6}" type="datetimeFigureOut">
               <a:rPr lang="en-US" smtClean="0"/>
-              <a:t>05/20/2026</a:t>
+              <a:t>6/17/26</a:t>
             </a:fld>
             <a:endParaRPr lang="en-US"/>
           </a:p>
@@ -464,7 +464,7 @@
     </p:spTree>
     <p:extLst>
       <p:ext uri="{BB962C8B-B14F-4D97-AF65-F5344CB8AC3E}">
-        <p14:creationId xmlns:p14="http://schemas.microsoft.com/office/powerpoint/2010/main" val="1801570307"/>
+        <p14:creationId xmlns:p14="http://schemas.microsoft.com/office/powerpoint/2010/main" val="1254845970"/>
       </p:ext>
     </p:extLst>
   </p:cSld>
@@ -503,8 +503,8 @@
         </p:nvSpPr>
         <p:spPr>
           <a:xfrm>
-            <a:off x="4907756" y="146050"/>
-            <a:ext cx="1478756" cy="2324735"/>
+            <a:off x="4907756" y="126610"/>
+            <a:ext cx="1478756" cy="2015309"/>
           </a:xfrm>
         </p:spPr>
         <p:txBody>
@@ -531,8 +531,8 @@
         </p:nvSpPr>
         <p:spPr>
           <a:xfrm>
-            <a:off x="471487" y="146050"/>
-            <a:ext cx="4350544" cy="2324735"/>
+            <a:off x="471487" y="126610"/>
+            <a:ext cx="4350544" cy="2015309"/>
           </a:xfrm>
         </p:spPr>
         <p:txBody>
@@ -593,7 +593,7 @@
           <a:p>
             <a:fld id="{C64808BA-7FDF-40FB-8D34-8FB57E054EF6}" type="datetimeFigureOut">
               <a:rPr lang="en-US" smtClean="0"/>
-              <a:t>05/20/2026</a:t>
+              <a:t>6/17/26</a:t>
             </a:fld>
             <a:endParaRPr lang="en-US"/>
           </a:p>
@@ -644,7 +644,7 @@
     </p:spTree>
     <p:extLst>
       <p:ext uri="{BB962C8B-B14F-4D97-AF65-F5344CB8AC3E}">
-        <p14:creationId xmlns:p14="http://schemas.microsoft.com/office/powerpoint/2010/main" val="999193685"/>
+        <p14:creationId xmlns:p14="http://schemas.microsoft.com/office/powerpoint/2010/main" val="713647191"/>
       </p:ext>
     </p:extLst>
   </p:cSld>
@@ -763,7 +763,7 @@
           <a:p>
             <a:fld id="{C64808BA-7FDF-40FB-8D34-8FB57E054EF6}" type="datetimeFigureOut">
               <a:rPr lang="en-US" smtClean="0"/>
-              <a:t>05/20/2026</a:t>
+              <a:t>6/17/26</a:t>
             </a:fld>
             <a:endParaRPr lang="en-US"/>
           </a:p>
@@ -814,7 +814,7 @@
     </p:spTree>
     <p:extLst>
       <p:ext uri="{BB962C8B-B14F-4D97-AF65-F5344CB8AC3E}">
-        <p14:creationId xmlns:p14="http://schemas.microsoft.com/office/powerpoint/2010/main" val="303246366"/>
+        <p14:creationId xmlns:p14="http://schemas.microsoft.com/office/powerpoint/2010/main" val="1860121911"/>
       </p:ext>
     </p:extLst>
   </p:cSld>
@@ -853,15 +853,15 @@
         </p:nvSpPr>
         <p:spPr>
           <a:xfrm>
-            <a:off x="467916" y="683895"/>
-            <a:ext cx="5915025" cy="1141095"/>
+            <a:off x="467916" y="592868"/>
+            <a:ext cx="5915025" cy="989213"/>
           </a:xfrm>
         </p:spPr>
         <p:txBody>
           <a:bodyPr anchor="b"/>
           <a:lstStyle>
             <a:lvl1pPr>
-              <a:defRPr sz="2400"/>
+              <a:defRPr sz="2081"/>
             </a:lvl1pPr>
           </a:lstStyle>
           <a:p>
@@ -885,8 +885,8 @@
         </p:nvSpPr>
         <p:spPr>
           <a:xfrm>
-            <a:off x="467916" y="1835785"/>
-            <a:ext cx="5915025" cy="600075"/>
+            <a:off x="467916" y="1591439"/>
+            <a:ext cx="5915025" cy="520204"/>
           </a:xfrm>
         </p:spPr>
         <p:txBody>
@@ -894,7 +894,7 @@
           <a:lstStyle>
             <a:lvl1pPr marL="0" indent="0">
               <a:buNone/>
-              <a:defRPr sz="960">
+              <a:defRPr sz="832">
                 <a:solidFill>
                   <a:schemeClr val="tx1">
                     <a:tint val="82000"/>
@@ -902,9 +902,9 @@
                 </a:solidFill>
               </a:defRPr>
             </a:lvl1pPr>
-            <a:lvl2pPr marL="182880" indent="0">
+            <a:lvl2pPr marL="158557" indent="0">
               <a:buNone/>
-              <a:defRPr sz="800">
+              <a:defRPr sz="694">
                 <a:solidFill>
                   <a:schemeClr val="tx1">
                     <a:tint val="82000"/>
@@ -912,9 +912,9 @@
                 </a:solidFill>
               </a:defRPr>
             </a:lvl2pPr>
-            <a:lvl3pPr marL="365760" indent="0">
+            <a:lvl3pPr marL="317114" indent="0">
               <a:buNone/>
-              <a:defRPr sz="720">
+              <a:defRPr sz="624">
                 <a:solidFill>
                   <a:schemeClr val="tx1">
                     <a:tint val="82000"/>
@@ -922,9 +922,9 @@
                 </a:solidFill>
               </a:defRPr>
             </a:lvl3pPr>
-            <a:lvl4pPr marL="548640" indent="0">
+            <a:lvl4pPr marL="475671" indent="0">
               <a:buNone/>
-              <a:defRPr sz="640">
+              <a:defRPr sz="555">
                 <a:solidFill>
                   <a:schemeClr val="tx1">
                     <a:tint val="82000"/>
@@ -932,9 +932,9 @@
                 </a:solidFill>
               </a:defRPr>
             </a:lvl4pPr>
-            <a:lvl5pPr marL="731520" indent="0">
+            <a:lvl5pPr marL="634228" indent="0">
               <a:buNone/>
-              <a:defRPr sz="640">
+              <a:defRPr sz="555">
                 <a:solidFill>
                   <a:schemeClr val="tx1">
                     <a:tint val="82000"/>
@@ -942,9 +942,9 @@
                 </a:solidFill>
               </a:defRPr>
             </a:lvl5pPr>
-            <a:lvl6pPr marL="914400" indent="0">
+            <a:lvl6pPr marL="792785" indent="0">
               <a:buNone/>
-              <a:defRPr sz="640">
+              <a:defRPr sz="555">
                 <a:solidFill>
                   <a:schemeClr val="tx1">
                     <a:tint val="82000"/>
@@ -952,9 +952,9 @@
                 </a:solidFill>
               </a:defRPr>
             </a:lvl6pPr>
-            <a:lvl7pPr marL="1097280" indent="0">
+            <a:lvl7pPr marL="951342" indent="0">
               <a:buNone/>
-              <a:defRPr sz="640">
+              <a:defRPr sz="555">
                 <a:solidFill>
                   <a:schemeClr val="tx1">
                     <a:tint val="82000"/>
@@ -962,9 +962,9 @@
                 </a:solidFill>
               </a:defRPr>
             </a:lvl7pPr>
-            <a:lvl8pPr marL="1280160" indent="0">
+            <a:lvl8pPr marL="1109899" indent="0">
               <a:buNone/>
-              <a:defRPr sz="640">
+              <a:defRPr sz="555">
                 <a:solidFill>
                   <a:schemeClr val="tx1">
                     <a:tint val="82000"/>
@@ -972,9 +972,9 @@
                 </a:solidFill>
               </a:defRPr>
             </a:lvl8pPr>
-            <a:lvl9pPr marL="1463040" indent="0">
+            <a:lvl9pPr marL="1268456" indent="0">
               <a:buNone/>
-              <a:defRPr sz="640">
+              <a:defRPr sz="555">
                 <a:solidFill>
                   <a:schemeClr val="tx1">
                     <a:tint val="82000"/>
@@ -1009,7 +1009,7 @@
           <a:p>
             <a:fld id="{C64808BA-7FDF-40FB-8D34-8FB57E054EF6}" type="datetimeFigureOut">
               <a:rPr lang="en-US" smtClean="0"/>
-              <a:t>05/20/2026</a:t>
+              <a:t>6/17/26</a:t>
             </a:fld>
             <a:endParaRPr lang="en-US"/>
           </a:p>
@@ -1060,7 +1060,7 @@
     </p:spTree>
     <p:extLst>
       <p:ext uri="{BB962C8B-B14F-4D97-AF65-F5344CB8AC3E}">
-        <p14:creationId xmlns:p14="http://schemas.microsoft.com/office/powerpoint/2010/main" val="2424951598"/>
+        <p14:creationId xmlns:p14="http://schemas.microsoft.com/office/powerpoint/2010/main" val="3799757394"/>
       </p:ext>
     </p:extLst>
   </p:cSld>
@@ -1122,8 +1122,8 @@
         </p:nvSpPr>
         <p:spPr>
           <a:xfrm>
-            <a:off x="471488" y="730250"/>
-            <a:ext cx="2914650" cy="1740535"/>
+            <a:off x="471488" y="633052"/>
+            <a:ext cx="2914650" cy="1508867"/>
           </a:xfrm>
         </p:spPr>
         <p:txBody>
@@ -1179,8 +1179,8 @@
         </p:nvSpPr>
         <p:spPr>
           <a:xfrm>
-            <a:off x="3471863" y="730250"/>
-            <a:ext cx="2914650" cy="1740535"/>
+            <a:off x="3471863" y="633052"/>
+            <a:ext cx="2914650" cy="1508867"/>
           </a:xfrm>
         </p:spPr>
         <p:txBody>
@@ -1241,7 +1241,7 @@
           <a:p>
             <a:fld id="{C64808BA-7FDF-40FB-8D34-8FB57E054EF6}" type="datetimeFigureOut">
               <a:rPr lang="en-US" smtClean="0"/>
-              <a:t>05/20/2026</a:t>
+              <a:t>6/17/26</a:t>
             </a:fld>
             <a:endParaRPr lang="en-US"/>
           </a:p>
@@ -1292,7 +1292,7 @@
     </p:spTree>
     <p:extLst>
       <p:ext uri="{BB962C8B-B14F-4D97-AF65-F5344CB8AC3E}">
-        <p14:creationId xmlns:p14="http://schemas.microsoft.com/office/powerpoint/2010/main" val="108524429"/>
+        <p14:creationId xmlns:p14="http://schemas.microsoft.com/office/powerpoint/2010/main" val="2977413312"/>
       </p:ext>
     </p:extLst>
   </p:cSld>
@@ -1331,8 +1331,8 @@
         </p:nvSpPr>
         <p:spPr>
           <a:xfrm>
-            <a:off x="472381" y="146050"/>
-            <a:ext cx="5915025" cy="530225"/>
+            <a:off x="472381" y="126611"/>
+            <a:ext cx="5915025" cy="459651"/>
           </a:xfrm>
         </p:spPr>
         <p:txBody>
@@ -1359,8 +1359,8 @@
         </p:nvSpPr>
         <p:spPr>
           <a:xfrm>
-            <a:off x="472381" y="672465"/>
-            <a:ext cx="2901255" cy="329565"/>
+            <a:off x="472381" y="582959"/>
+            <a:ext cx="2901255" cy="285699"/>
           </a:xfrm>
         </p:spPr>
         <p:txBody>
@@ -1368,39 +1368,39 @@
           <a:lstStyle>
             <a:lvl1pPr marL="0" indent="0">
               <a:buNone/>
-              <a:defRPr sz="960" b="1"/>
+              <a:defRPr sz="832" b="1"/>
             </a:lvl1pPr>
-            <a:lvl2pPr marL="182880" indent="0">
+            <a:lvl2pPr marL="158557" indent="0">
               <a:buNone/>
-              <a:defRPr sz="800" b="1"/>
+              <a:defRPr sz="694" b="1"/>
             </a:lvl2pPr>
-            <a:lvl3pPr marL="365760" indent="0">
+            <a:lvl3pPr marL="317114" indent="0">
               <a:buNone/>
-              <a:defRPr sz="720" b="1"/>
+              <a:defRPr sz="624" b="1"/>
             </a:lvl3pPr>
-            <a:lvl4pPr marL="548640" indent="0">
+            <a:lvl4pPr marL="475671" indent="0">
               <a:buNone/>
-              <a:defRPr sz="640" b="1"/>
+              <a:defRPr sz="555" b="1"/>
             </a:lvl4pPr>
-            <a:lvl5pPr marL="731520" indent="0">
+            <a:lvl5pPr marL="634228" indent="0">
               <a:buNone/>
-              <a:defRPr sz="640" b="1"/>
+              <a:defRPr sz="555" b="1"/>
             </a:lvl5pPr>
-            <a:lvl6pPr marL="914400" indent="0">
+            <a:lvl6pPr marL="792785" indent="0">
               <a:buNone/>
-              <a:defRPr sz="640" b="1"/>
+              <a:defRPr sz="555" b="1"/>
             </a:lvl6pPr>
-            <a:lvl7pPr marL="1097280" indent="0">
+            <a:lvl7pPr marL="951342" indent="0">
               <a:buNone/>
-              <a:defRPr sz="640" b="1"/>
+              <a:defRPr sz="555" b="1"/>
             </a:lvl7pPr>
-            <a:lvl8pPr marL="1280160" indent="0">
+            <a:lvl8pPr marL="1109899" indent="0">
               <a:buNone/>
-              <a:defRPr sz="640" b="1"/>
+              <a:defRPr sz="555" b="1"/>
             </a:lvl8pPr>
-            <a:lvl9pPr marL="1463040" indent="0">
+            <a:lvl9pPr marL="1268456" indent="0">
               <a:buNone/>
-              <a:defRPr sz="640" b="1"/>
+              <a:defRPr sz="555" b="1"/>
             </a:lvl9pPr>
           </a:lstStyle>
           <a:p>
@@ -1424,8 +1424,8 @@
         </p:nvSpPr>
         <p:spPr>
           <a:xfrm>
-            <a:off x="472381" y="1002030"/>
-            <a:ext cx="2901255" cy="1473835"/>
+            <a:off x="472381" y="868658"/>
+            <a:ext cx="2901255" cy="1277665"/>
           </a:xfrm>
         </p:spPr>
         <p:txBody>
@@ -1481,8 +1481,8 @@
         </p:nvSpPr>
         <p:spPr>
           <a:xfrm>
-            <a:off x="3471863" y="672465"/>
-            <a:ext cx="2915543" cy="329565"/>
+            <a:off x="3471863" y="582959"/>
+            <a:ext cx="2915543" cy="285699"/>
           </a:xfrm>
         </p:spPr>
         <p:txBody>
@@ -1490,39 +1490,39 @@
           <a:lstStyle>
             <a:lvl1pPr marL="0" indent="0">
               <a:buNone/>
-              <a:defRPr sz="960" b="1"/>
+              <a:defRPr sz="832" b="1"/>
             </a:lvl1pPr>
-            <a:lvl2pPr marL="182880" indent="0">
+            <a:lvl2pPr marL="158557" indent="0">
               <a:buNone/>
-              <a:defRPr sz="800" b="1"/>
+              <a:defRPr sz="694" b="1"/>
             </a:lvl2pPr>
-            <a:lvl3pPr marL="365760" indent="0">
+            <a:lvl3pPr marL="317114" indent="0">
               <a:buNone/>
-              <a:defRPr sz="720" b="1"/>
+              <a:defRPr sz="624" b="1"/>
             </a:lvl3pPr>
-            <a:lvl4pPr marL="548640" indent="0">
+            <a:lvl4pPr marL="475671" indent="0">
               <a:buNone/>
-              <a:defRPr sz="640" b="1"/>
+              <a:defRPr sz="555" b="1"/>
             </a:lvl4pPr>
-            <a:lvl5pPr marL="731520" indent="0">
+            <a:lvl5pPr marL="634228" indent="0">
               <a:buNone/>
-              <a:defRPr sz="640" b="1"/>
+              <a:defRPr sz="555" b="1"/>
             </a:lvl5pPr>
-            <a:lvl6pPr marL="914400" indent="0">
+            <a:lvl6pPr marL="792785" indent="0">
               <a:buNone/>
-              <a:defRPr sz="640" b="1"/>
+              <a:defRPr sz="555" b="1"/>
             </a:lvl6pPr>
-            <a:lvl7pPr marL="1097280" indent="0">
+            <a:lvl7pPr marL="951342" indent="0">
               <a:buNone/>
-              <a:defRPr sz="640" b="1"/>
+              <a:defRPr sz="555" b="1"/>
             </a:lvl7pPr>
-            <a:lvl8pPr marL="1280160" indent="0">
+            <a:lvl8pPr marL="1109899" indent="0">
               <a:buNone/>
-              <a:defRPr sz="640" b="1"/>
+              <a:defRPr sz="555" b="1"/>
             </a:lvl8pPr>
-            <a:lvl9pPr marL="1463040" indent="0">
+            <a:lvl9pPr marL="1268456" indent="0">
               <a:buNone/>
-              <a:defRPr sz="640" b="1"/>
+              <a:defRPr sz="555" b="1"/>
             </a:lvl9pPr>
           </a:lstStyle>
           <a:p>
@@ -1546,8 +1546,8 @@
         </p:nvSpPr>
         <p:spPr>
           <a:xfrm>
-            <a:off x="3471863" y="1002030"/>
-            <a:ext cx="2915543" cy="1473835"/>
+            <a:off x="3471863" y="868658"/>
+            <a:ext cx="2915543" cy="1277665"/>
           </a:xfrm>
         </p:spPr>
         <p:txBody>
@@ -1608,7 +1608,7 @@
           <a:p>
             <a:fld id="{C64808BA-7FDF-40FB-8D34-8FB57E054EF6}" type="datetimeFigureOut">
               <a:rPr lang="en-US" smtClean="0"/>
-              <a:t>05/20/2026</a:t>
+              <a:t>6/17/26</a:t>
             </a:fld>
             <a:endParaRPr lang="en-US"/>
           </a:p>
@@ -1659,7 +1659,7 @@
     </p:spTree>
     <p:extLst>
       <p:ext uri="{BB962C8B-B14F-4D97-AF65-F5344CB8AC3E}">
-        <p14:creationId xmlns:p14="http://schemas.microsoft.com/office/powerpoint/2010/main" val="3427757382"/>
+        <p14:creationId xmlns:p14="http://schemas.microsoft.com/office/powerpoint/2010/main" val="1167736346"/>
       </p:ext>
     </p:extLst>
   </p:cSld>
@@ -1726,7 +1726,7 @@
           <a:p>
             <a:fld id="{C64808BA-7FDF-40FB-8D34-8FB57E054EF6}" type="datetimeFigureOut">
               <a:rPr lang="en-US" smtClean="0"/>
-              <a:t>05/20/2026</a:t>
+              <a:t>6/17/26</a:t>
             </a:fld>
             <a:endParaRPr lang="en-US"/>
           </a:p>
@@ -1777,7 +1777,7 @@
     </p:spTree>
     <p:extLst>
       <p:ext uri="{BB962C8B-B14F-4D97-AF65-F5344CB8AC3E}">
-        <p14:creationId xmlns:p14="http://schemas.microsoft.com/office/powerpoint/2010/main" val="4175054851"/>
+        <p14:creationId xmlns:p14="http://schemas.microsoft.com/office/powerpoint/2010/main" val="3031876625"/>
       </p:ext>
     </p:extLst>
   </p:cSld>
@@ -1821,7 +1821,7 @@
           <a:p>
             <a:fld id="{C64808BA-7FDF-40FB-8D34-8FB57E054EF6}" type="datetimeFigureOut">
               <a:rPr lang="en-US" smtClean="0"/>
-              <a:t>05/20/2026</a:t>
+              <a:t>6/17/26</a:t>
             </a:fld>
             <a:endParaRPr lang="en-US"/>
           </a:p>
@@ -1872,7 +1872,7 @@
     </p:spTree>
     <p:extLst>
       <p:ext uri="{BB962C8B-B14F-4D97-AF65-F5344CB8AC3E}">
-        <p14:creationId xmlns:p14="http://schemas.microsoft.com/office/powerpoint/2010/main" val="2125007663"/>
+        <p14:creationId xmlns:p14="http://schemas.microsoft.com/office/powerpoint/2010/main" val="965331080"/>
       </p:ext>
     </p:extLst>
   </p:cSld>
@@ -1911,15 +1911,15 @@
         </p:nvSpPr>
         <p:spPr>
           <a:xfrm>
-            <a:off x="472381" y="182880"/>
-            <a:ext cx="2211883" cy="640080"/>
+            <a:off x="472381" y="158538"/>
+            <a:ext cx="2211883" cy="554884"/>
           </a:xfrm>
         </p:spPr>
         <p:txBody>
           <a:bodyPr anchor="b"/>
           <a:lstStyle>
             <a:lvl1pPr>
-              <a:defRPr sz="1280"/>
+              <a:defRPr sz="1110"/>
             </a:lvl1pPr>
           </a:lstStyle>
           <a:p>
@@ -1943,39 +1943,39 @@
         </p:nvSpPr>
         <p:spPr>
           <a:xfrm>
-            <a:off x="2915543" y="394970"/>
-            <a:ext cx="3471863" cy="1949450"/>
+            <a:off x="2915543" y="342399"/>
+            <a:ext cx="3471863" cy="1689975"/>
           </a:xfrm>
         </p:spPr>
         <p:txBody>
           <a:bodyPr/>
           <a:lstStyle>
             <a:lvl1pPr>
-              <a:defRPr sz="1280"/>
+              <a:defRPr sz="1110"/>
             </a:lvl1pPr>
             <a:lvl2pPr>
-              <a:defRPr sz="1120"/>
+              <a:defRPr sz="971"/>
             </a:lvl2pPr>
             <a:lvl3pPr>
-              <a:defRPr sz="960"/>
+              <a:defRPr sz="832"/>
             </a:lvl3pPr>
             <a:lvl4pPr>
-              <a:defRPr sz="800"/>
+              <a:defRPr sz="694"/>
             </a:lvl4pPr>
             <a:lvl5pPr>
-              <a:defRPr sz="800"/>
+              <a:defRPr sz="694"/>
             </a:lvl5pPr>
             <a:lvl6pPr>
-              <a:defRPr sz="800"/>
+              <a:defRPr sz="694"/>
             </a:lvl6pPr>
             <a:lvl7pPr>
-              <a:defRPr sz="800"/>
+              <a:defRPr sz="694"/>
             </a:lvl7pPr>
             <a:lvl8pPr>
-              <a:defRPr sz="800"/>
+              <a:defRPr sz="694"/>
             </a:lvl8pPr>
             <a:lvl9pPr>
-              <a:defRPr sz="800"/>
+              <a:defRPr sz="694"/>
             </a:lvl9pPr>
           </a:lstStyle>
           <a:p>
@@ -2028,8 +2028,8 @@
         </p:nvSpPr>
         <p:spPr>
           <a:xfrm>
-            <a:off x="472381" y="822960"/>
-            <a:ext cx="2211883" cy="1524635"/>
+            <a:off x="472381" y="713423"/>
+            <a:ext cx="2211883" cy="1321703"/>
           </a:xfrm>
         </p:spPr>
         <p:txBody>
@@ -2037,39 +2037,39 @@
           <a:lstStyle>
             <a:lvl1pPr marL="0" indent="0">
               <a:buNone/>
-              <a:defRPr sz="640"/>
+              <a:defRPr sz="555"/>
             </a:lvl1pPr>
-            <a:lvl2pPr marL="182880" indent="0">
+            <a:lvl2pPr marL="158557" indent="0">
               <a:buNone/>
-              <a:defRPr sz="560"/>
+              <a:defRPr sz="486"/>
             </a:lvl2pPr>
-            <a:lvl3pPr marL="365760" indent="0">
+            <a:lvl3pPr marL="317114" indent="0">
               <a:buNone/>
-              <a:defRPr sz="480"/>
+              <a:defRPr sz="416"/>
             </a:lvl3pPr>
-            <a:lvl4pPr marL="548640" indent="0">
+            <a:lvl4pPr marL="475671" indent="0">
               <a:buNone/>
-              <a:defRPr sz="400"/>
+              <a:defRPr sz="347"/>
             </a:lvl4pPr>
-            <a:lvl5pPr marL="731520" indent="0">
+            <a:lvl5pPr marL="634228" indent="0">
               <a:buNone/>
-              <a:defRPr sz="400"/>
+              <a:defRPr sz="347"/>
             </a:lvl5pPr>
-            <a:lvl6pPr marL="914400" indent="0">
+            <a:lvl6pPr marL="792785" indent="0">
               <a:buNone/>
-              <a:defRPr sz="400"/>
+              <a:defRPr sz="347"/>
             </a:lvl6pPr>
-            <a:lvl7pPr marL="1097280" indent="0">
+            <a:lvl7pPr marL="951342" indent="0">
               <a:buNone/>
-              <a:defRPr sz="400"/>
+              <a:defRPr sz="347"/>
             </a:lvl7pPr>
-            <a:lvl8pPr marL="1280160" indent="0">
+            <a:lvl8pPr marL="1109899" indent="0">
               <a:buNone/>
-              <a:defRPr sz="400"/>
+              <a:defRPr sz="347"/>
             </a:lvl8pPr>
-            <a:lvl9pPr marL="1463040" indent="0">
+            <a:lvl9pPr marL="1268456" indent="0">
               <a:buNone/>
-              <a:defRPr sz="400"/>
+              <a:defRPr sz="347"/>
             </a:lvl9pPr>
           </a:lstStyle>
           <a:p>
@@ -2098,7 +2098,7 @@
           <a:p>
             <a:fld id="{C64808BA-7FDF-40FB-8D34-8FB57E054EF6}" type="datetimeFigureOut">
               <a:rPr lang="en-US" smtClean="0"/>
-              <a:t>05/20/2026</a:t>
+              <a:t>6/17/26</a:t>
             </a:fld>
             <a:endParaRPr lang="en-US"/>
           </a:p>
@@ -2149,7 +2149,7 @@
     </p:spTree>
     <p:extLst>
       <p:ext uri="{BB962C8B-B14F-4D97-AF65-F5344CB8AC3E}">
-        <p14:creationId xmlns:p14="http://schemas.microsoft.com/office/powerpoint/2010/main" val="1731406443"/>
+        <p14:creationId xmlns:p14="http://schemas.microsoft.com/office/powerpoint/2010/main" val="1757848993"/>
       </p:ext>
     </p:extLst>
   </p:cSld>
@@ -2188,15 +2188,15 @@
         </p:nvSpPr>
         <p:spPr>
           <a:xfrm>
-            <a:off x="472381" y="182880"/>
-            <a:ext cx="2211883" cy="640080"/>
+            <a:off x="472381" y="158538"/>
+            <a:ext cx="2211883" cy="554884"/>
           </a:xfrm>
         </p:spPr>
         <p:txBody>
           <a:bodyPr anchor="b"/>
           <a:lstStyle>
             <a:lvl1pPr>
-              <a:defRPr sz="1280"/>
+              <a:defRPr sz="1110"/>
             </a:lvl1pPr>
           </a:lstStyle>
           <a:p>
@@ -2220,8 +2220,8 @@
         </p:nvSpPr>
         <p:spPr>
           <a:xfrm>
-            <a:off x="2915543" y="394970"/>
-            <a:ext cx="3471863" cy="1949450"/>
+            <a:off x="2915543" y="342399"/>
+            <a:ext cx="3471863" cy="1689975"/>
           </a:xfrm>
         </p:spPr>
         <p:txBody>
@@ -2229,39 +2229,39 @@
           <a:lstStyle>
             <a:lvl1pPr marL="0" indent="0">
               <a:buNone/>
-              <a:defRPr sz="1280"/>
+              <a:defRPr sz="1110"/>
             </a:lvl1pPr>
-            <a:lvl2pPr marL="182880" indent="0">
+            <a:lvl2pPr marL="158557" indent="0">
               <a:buNone/>
-              <a:defRPr sz="1120"/>
+              <a:defRPr sz="971"/>
             </a:lvl2pPr>
-            <a:lvl3pPr marL="365760" indent="0">
+            <a:lvl3pPr marL="317114" indent="0">
               <a:buNone/>
-              <a:defRPr sz="960"/>
+              <a:defRPr sz="832"/>
             </a:lvl3pPr>
-            <a:lvl4pPr marL="548640" indent="0">
+            <a:lvl4pPr marL="475671" indent="0">
               <a:buNone/>
-              <a:defRPr sz="800"/>
+              <a:defRPr sz="694"/>
             </a:lvl4pPr>
-            <a:lvl5pPr marL="731520" indent="0">
+            <a:lvl5pPr marL="634228" indent="0">
               <a:buNone/>
-              <a:defRPr sz="800"/>
+              <a:defRPr sz="694"/>
             </a:lvl5pPr>
-            <a:lvl6pPr marL="914400" indent="0">
+            <a:lvl6pPr marL="792785" indent="0">
               <a:buNone/>
-              <a:defRPr sz="800"/>
+              <a:defRPr sz="694"/>
             </a:lvl6pPr>
-            <a:lvl7pPr marL="1097280" indent="0">
+            <a:lvl7pPr marL="951342" indent="0">
               <a:buNone/>
-              <a:defRPr sz="800"/>
+              <a:defRPr sz="694"/>
             </a:lvl7pPr>
-            <a:lvl8pPr marL="1280160" indent="0">
+            <a:lvl8pPr marL="1109899" indent="0">
               <a:buNone/>
-              <a:defRPr sz="800"/>
+              <a:defRPr sz="694"/>
             </a:lvl8pPr>
-            <a:lvl9pPr marL="1463040" indent="0">
+            <a:lvl9pPr marL="1268456" indent="0">
               <a:buNone/>
-              <a:defRPr sz="800"/>
+              <a:defRPr sz="694"/>
             </a:lvl9pPr>
           </a:lstStyle>
           <a:p>
@@ -2285,8 +2285,8 @@
         </p:nvSpPr>
         <p:spPr>
           <a:xfrm>
-            <a:off x="472381" y="822960"/>
-            <a:ext cx="2211883" cy="1524635"/>
+            <a:off x="472381" y="713423"/>
+            <a:ext cx="2211883" cy="1321703"/>
           </a:xfrm>
         </p:spPr>
         <p:txBody>
@@ -2294,39 +2294,39 @@
           <a:lstStyle>
             <a:lvl1pPr marL="0" indent="0">
               <a:buNone/>
-              <a:defRPr sz="640"/>
+              <a:defRPr sz="555"/>
             </a:lvl1pPr>
-            <a:lvl2pPr marL="182880" indent="0">
+            <a:lvl2pPr marL="158557" indent="0">
               <a:buNone/>
-              <a:defRPr sz="560"/>
+              <a:defRPr sz="486"/>
             </a:lvl2pPr>
-            <a:lvl3pPr marL="365760" indent="0">
+            <a:lvl3pPr marL="317114" indent="0">
               <a:buNone/>
-              <a:defRPr sz="480"/>
+              <a:defRPr sz="416"/>
             </a:lvl3pPr>
-            <a:lvl4pPr marL="548640" indent="0">
+            <a:lvl4pPr marL="475671" indent="0">
               <a:buNone/>
-              <a:defRPr sz="400"/>
+              <a:defRPr sz="347"/>
             </a:lvl4pPr>
-            <a:lvl5pPr marL="731520" indent="0">
+            <a:lvl5pPr marL="634228" indent="0">
               <a:buNone/>
-              <a:defRPr sz="400"/>
+              <a:defRPr sz="347"/>
             </a:lvl5pPr>
-            <a:lvl6pPr marL="914400" indent="0">
+            <a:lvl6pPr marL="792785" indent="0">
               <a:buNone/>
-              <a:defRPr sz="400"/>
+              <a:defRPr sz="347"/>
             </a:lvl6pPr>
-            <a:lvl7pPr marL="1097280" indent="0">
+            <a:lvl7pPr marL="951342" indent="0">
               <a:buNone/>
-              <a:defRPr sz="400"/>
+              <a:defRPr sz="347"/>
             </a:lvl7pPr>
-            <a:lvl8pPr marL="1280160" indent="0">
+            <a:lvl8pPr marL="1109899" indent="0">
               <a:buNone/>
-              <a:defRPr sz="400"/>
+              <a:defRPr sz="347"/>
             </a:lvl8pPr>
-            <a:lvl9pPr marL="1463040" indent="0">
+            <a:lvl9pPr marL="1268456" indent="0">
               <a:buNone/>
-              <a:defRPr sz="400"/>
+              <a:defRPr sz="347"/>
             </a:lvl9pPr>
           </a:lstStyle>
           <a:p>
@@ -2355,7 +2355,7 @@
           <a:p>
             <a:fld id="{C64808BA-7FDF-40FB-8D34-8FB57E054EF6}" type="datetimeFigureOut">
               <a:rPr lang="en-US" smtClean="0"/>
-              <a:t>05/20/2026</a:t>
+              <a:t>6/17/26</a:t>
             </a:fld>
             <a:endParaRPr lang="en-US"/>
           </a:p>
@@ -2406,7 +2406,7 @@
     </p:spTree>
     <p:extLst>
       <p:ext uri="{BB962C8B-B14F-4D97-AF65-F5344CB8AC3E}">
-        <p14:creationId xmlns:p14="http://schemas.microsoft.com/office/powerpoint/2010/main" val="2954628197"/>
+        <p14:creationId xmlns:p14="http://schemas.microsoft.com/office/powerpoint/2010/main" val="4152371330"/>
       </p:ext>
     </p:extLst>
   </p:cSld>
@@ -2450,8 +2450,8 @@
         </p:nvSpPr>
         <p:spPr>
           <a:xfrm>
-            <a:off x="471488" y="146050"/>
-            <a:ext cx="5915025" cy="530225"/>
+            <a:off x="471488" y="126611"/>
+            <a:ext cx="5915025" cy="459651"/>
           </a:xfrm>
           <a:prstGeom prst="rect">
             <a:avLst/>
@@ -2483,8 +2483,8 @@
         </p:nvSpPr>
         <p:spPr>
           <a:xfrm>
-            <a:off x="471488" y="730250"/>
-            <a:ext cx="5915025" cy="1740535"/>
+            <a:off x="471488" y="633052"/>
+            <a:ext cx="5915025" cy="1508867"/>
           </a:xfrm>
           <a:prstGeom prst="rect">
             <a:avLst/>
@@ -2545,8 +2545,8 @@
         </p:nvSpPr>
         <p:spPr>
           <a:xfrm>
-            <a:off x="471488" y="2542540"/>
-            <a:ext cx="1543050" cy="146050"/>
+            <a:off x="471488" y="2204124"/>
+            <a:ext cx="1543050" cy="126610"/>
           </a:xfrm>
           <a:prstGeom prst="rect">
             <a:avLst/>
@@ -2556,7 +2556,7 @@
           <a:bodyPr vert="horz" lIns="91440" tIns="45720" rIns="91440" bIns="45720" rtlCol="0" anchor="ctr"/>
           <a:lstStyle>
             <a:lvl1pPr algn="l">
-              <a:defRPr sz="480">
+              <a:defRPr sz="416">
                 <a:solidFill>
                   <a:schemeClr val="tx1">
                     <a:tint val="82000"/>
@@ -2568,7 +2568,7 @@
           <a:p>
             <a:fld id="{C64808BA-7FDF-40FB-8D34-8FB57E054EF6}" type="datetimeFigureOut">
               <a:rPr lang="en-US" smtClean="0"/>
-              <a:t>05/20/2026</a:t>
+              <a:t>6/17/26</a:t>
             </a:fld>
             <a:endParaRPr lang="en-US"/>
           </a:p>
@@ -2586,8 +2586,8 @@
         </p:nvSpPr>
         <p:spPr>
           <a:xfrm>
-            <a:off x="2271713" y="2542540"/>
-            <a:ext cx="2314575" cy="146050"/>
+            <a:off x="2271713" y="2204124"/>
+            <a:ext cx="2314575" cy="126610"/>
           </a:xfrm>
           <a:prstGeom prst="rect">
             <a:avLst/>
@@ -2597,7 +2597,7 @@
           <a:bodyPr vert="horz" lIns="91440" tIns="45720" rIns="91440" bIns="45720" rtlCol="0" anchor="ctr"/>
           <a:lstStyle>
             <a:lvl1pPr algn="ctr">
-              <a:defRPr sz="480">
+              <a:defRPr sz="416">
                 <a:solidFill>
                   <a:schemeClr val="tx1">
                     <a:tint val="82000"/>
@@ -2623,8 +2623,8 @@
         </p:nvSpPr>
         <p:spPr>
           <a:xfrm>
-            <a:off x="4843463" y="2542540"/>
-            <a:ext cx="1543050" cy="146050"/>
+            <a:off x="4843463" y="2204124"/>
+            <a:ext cx="1543050" cy="126610"/>
           </a:xfrm>
           <a:prstGeom prst="rect">
             <a:avLst/>
@@ -2634,7 +2634,7 @@
           <a:bodyPr vert="horz" lIns="91440" tIns="45720" rIns="91440" bIns="45720" rtlCol="0" anchor="ctr"/>
           <a:lstStyle>
             <a:lvl1pPr algn="r">
-              <a:defRPr sz="480">
+              <a:defRPr sz="416">
                 <a:solidFill>
                   <a:schemeClr val="tx1">
                     <a:tint val="82000"/>
@@ -2655,27 +2655,27 @@
     </p:spTree>
     <p:extLst>
       <p:ext uri="{BB962C8B-B14F-4D97-AF65-F5344CB8AC3E}">
-        <p14:creationId xmlns:p14="http://schemas.microsoft.com/office/powerpoint/2010/main" val="1563488321"/>
+        <p14:creationId xmlns:p14="http://schemas.microsoft.com/office/powerpoint/2010/main" val="408966698"/>
       </p:ext>
     </p:extLst>
   </p:cSld>
   <p:clrMap bg1="lt1" tx1="dk1" bg2="lt2" tx2="dk2" accent1="accent1" accent2="accent2" accent3="accent3" accent4="accent4" accent5="accent5" accent6="accent6" hlink="hlink" folHlink="folHlink"/>
   <p:sldLayoutIdLst>
-    <p:sldLayoutId id="2147483745" r:id="rId1"/>
-    <p:sldLayoutId id="2147483746" r:id="rId2"/>
-    <p:sldLayoutId id="2147483747" r:id="rId3"/>
-    <p:sldLayoutId id="2147483748" r:id="rId4"/>
-    <p:sldLayoutId id="2147483749" r:id="rId5"/>
-    <p:sldLayoutId id="2147483750" r:id="rId6"/>
-    <p:sldLayoutId id="2147483751" r:id="rId7"/>
-    <p:sldLayoutId id="2147483752" r:id="rId8"/>
-    <p:sldLayoutId id="2147483753" r:id="rId9"/>
-    <p:sldLayoutId id="2147483754" r:id="rId10"/>
-    <p:sldLayoutId id="2147483755" r:id="rId11"/>
+    <p:sldLayoutId id="2147483781" r:id="rId1"/>
+    <p:sldLayoutId id="2147483782" r:id="rId2"/>
+    <p:sldLayoutId id="2147483783" r:id="rId3"/>
+    <p:sldLayoutId id="2147483784" r:id="rId4"/>
+    <p:sldLayoutId id="2147483785" r:id="rId5"/>
+    <p:sldLayoutId id="2147483786" r:id="rId6"/>
+    <p:sldLayoutId id="2147483787" r:id="rId7"/>
+    <p:sldLayoutId id="2147483788" r:id="rId8"/>
+    <p:sldLayoutId id="2147483789" r:id="rId9"/>
+    <p:sldLayoutId id="2147483790" r:id="rId10"/>
+    <p:sldLayoutId id="2147483791" r:id="rId11"/>
   </p:sldLayoutIdLst>
   <p:txStyles>
     <p:titleStyle>
-      <a:lvl1pPr algn="l" defTabSz="365760" rtl="0" eaLnBrk="1" latinLnBrk="0" hangingPunct="1">
+      <a:lvl1pPr algn="l" defTabSz="317114" rtl="0" eaLnBrk="1" latinLnBrk="0" hangingPunct="1">
         <a:lnSpc>
           <a:spcPct val="90000"/>
         </a:lnSpc>
@@ -2683,7 +2683,7 @@
           <a:spcPct val="0"/>
         </a:spcBef>
         <a:buNone/>
-        <a:defRPr sz="1760" kern="1200">
+        <a:defRPr sz="1526" kern="1200">
           <a:solidFill>
             <a:schemeClr val="tx1"/>
           </a:solidFill>
@@ -2694,16 +2694,16 @@
       </a:lvl1pPr>
     </p:titleStyle>
     <p:bodyStyle>
-      <a:lvl1pPr marL="91440" indent="-91440" algn="l" defTabSz="365760" rtl="0" eaLnBrk="1" latinLnBrk="0" hangingPunct="1">
+      <a:lvl1pPr marL="79278" indent="-79278" algn="l" defTabSz="317114" rtl="0" eaLnBrk="1" latinLnBrk="0" hangingPunct="1">
         <a:lnSpc>
           <a:spcPct val="90000"/>
         </a:lnSpc>
         <a:spcBef>
-          <a:spcPts val="400"/>
+          <a:spcPts val="347"/>
         </a:spcBef>
         <a:buFont typeface="Arial" panose="020B0604020202020204" pitchFamily="34" charset="0"/>
         <a:buChar char="•"/>
-        <a:defRPr sz="1120" kern="1200">
+        <a:defRPr sz="971" kern="1200">
           <a:solidFill>
             <a:schemeClr val="tx1"/>
           </a:solidFill>
@@ -2712,16 +2712,16 @@
           <a:cs typeface="+mn-cs"/>
         </a:defRPr>
       </a:lvl1pPr>
-      <a:lvl2pPr marL="274320" indent="-91440" algn="l" defTabSz="365760" rtl="0" eaLnBrk="1" latinLnBrk="0" hangingPunct="1">
+      <a:lvl2pPr marL="237835" indent="-79278" algn="l" defTabSz="317114" rtl="0" eaLnBrk="1" latinLnBrk="0" hangingPunct="1">
         <a:lnSpc>
           <a:spcPct val="90000"/>
         </a:lnSpc>
         <a:spcBef>
-          <a:spcPts val="200"/>
+          <a:spcPts val="173"/>
         </a:spcBef>
         <a:buFont typeface="Arial" panose="020B0604020202020204" pitchFamily="34" charset="0"/>
         <a:buChar char="•"/>
-        <a:defRPr sz="960" kern="1200">
+        <a:defRPr sz="832" kern="1200">
           <a:solidFill>
             <a:schemeClr val="tx1"/>
           </a:solidFill>
@@ -2730,16 +2730,16 @@
           <a:cs typeface="+mn-cs"/>
         </a:defRPr>
       </a:lvl2pPr>
-      <a:lvl3pPr marL="457200" indent="-91440" algn="l" defTabSz="365760" rtl="0" eaLnBrk="1" latinLnBrk="0" hangingPunct="1">
+      <a:lvl3pPr marL="396392" indent="-79278" algn="l" defTabSz="317114" rtl="0" eaLnBrk="1" latinLnBrk="0" hangingPunct="1">
         <a:lnSpc>
           <a:spcPct val="90000"/>
         </a:lnSpc>
         <a:spcBef>
-          <a:spcPts val="200"/>
+          <a:spcPts val="173"/>
         </a:spcBef>
         <a:buFont typeface="Arial" panose="020B0604020202020204" pitchFamily="34" charset="0"/>
         <a:buChar char="•"/>
-        <a:defRPr sz="800" kern="1200">
+        <a:defRPr sz="694" kern="1200">
           <a:solidFill>
             <a:schemeClr val="tx1"/>
           </a:solidFill>
@@ -2748,16 +2748,16 @@
           <a:cs typeface="+mn-cs"/>
         </a:defRPr>
       </a:lvl3pPr>
-      <a:lvl4pPr marL="640080" indent="-91440" algn="l" defTabSz="365760" rtl="0" eaLnBrk="1" latinLnBrk="0" hangingPunct="1">
+      <a:lvl4pPr marL="554949" indent="-79278" algn="l" defTabSz="317114" rtl="0" eaLnBrk="1" latinLnBrk="0" hangingPunct="1">
         <a:lnSpc>
           <a:spcPct val="90000"/>
         </a:lnSpc>
         <a:spcBef>
-          <a:spcPts val="200"/>
+          <a:spcPts val="173"/>
         </a:spcBef>
         <a:buFont typeface="Arial" panose="020B0604020202020204" pitchFamily="34" charset="0"/>
         <a:buChar char="•"/>
-        <a:defRPr sz="720" kern="1200">
+        <a:defRPr sz="624" kern="1200">
           <a:solidFill>
             <a:schemeClr val="tx1"/>
           </a:solidFill>
@@ -2766,16 +2766,16 @@
           <a:cs typeface="+mn-cs"/>
         </a:defRPr>
       </a:lvl4pPr>
-      <a:lvl5pPr marL="822960" indent="-91440" algn="l" defTabSz="365760" rtl="0" eaLnBrk="1" latinLnBrk="0" hangingPunct="1">
+      <a:lvl5pPr marL="713506" indent="-79278" algn="l" defTabSz="317114" rtl="0" eaLnBrk="1" latinLnBrk="0" hangingPunct="1">
         <a:lnSpc>
           <a:spcPct val="90000"/>
         </a:lnSpc>
         <a:spcBef>
-          <a:spcPts val="200"/>
+          <a:spcPts val="173"/>
         </a:spcBef>
         <a:buFont typeface="Arial" panose="020B0604020202020204" pitchFamily="34" charset="0"/>
         <a:buChar char="•"/>
-        <a:defRPr sz="720" kern="1200">
+        <a:defRPr sz="624" kern="1200">
           <a:solidFill>
             <a:schemeClr val="tx1"/>
           </a:solidFill>
@@ -2784,16 +2784,16 @@
           <a:cs typeface="+mn-cs"/>
         </a:defRPr>
       </a:lvl5pPr>
-      <a:lvl6pPr marL="1005840" indent="-91440" algn="l" defTabSz="365760" rtl="0" eaLnBrk="1" latinLnBrk="0" hangingPunct="1">
+      <a:lvl6pPr marL="872063" indent="-79278" algn="l" defTabSz="317114" rtl="0" eaLnBrk="1" latinLnBrk="0" hangingPunct="1">
         <a:lnSpc>
           <a:spcPct val="90000"/>
         </a:lnSpc>
         <a:spcBef>
-          <a:spcPts val="200"/>
+          <a:spcPts val="173"/>
         </a:spcBef>
         <a:buFont typeface="Arial" panose="020B0604020202020204" pitchFamily="34" charset="0"/>
         <a:buChar char="•"/>
-        <a:defRPr sz="720" kern="1200">
+        <a:defRPr sz="624" kern="1200">
           <a:solidFill>
             <a:schemeClr val="tx1"/>
           </a:solidFill>
@@ -2802,16 +2802,16 @@
           <a:cs typeface="+mn-cs"/>
         </a:defRPr>
       </a:lvl6pPr>
-      <a:lvl7pPr marL="1188720" indent="-91440" algn="l" defTabSz="365760" rtl="0" eaLnBrk="1" latinLnBrk="0" hangingPunct="1">
+      <a:lvl7pPr marL="1030620" indent="-79278" algn="l" defTabSz="317114" rtl="0" eaLnBrk="1" latinLnBrk="0" hangingPunct="1">
         <a:lnSpc>
           <a:spcPct val="90000"/>
         </a:lnSpc>
         <a:spcBef>
-          <a:spcPts val="200"/>
+          <a:spcPts val="173"/>
         </a:spcBef>
         <a:buFont typeface="Arial" panose="020B0604020202020204" pitchFamily="34" charset="0"/>
         <a:buChar char="•"/>
-        <a:defRPr sz="720" kern="1200">
+        <a:defRPr sz="624" kern="1200">
           <a:solidFill>
             <a:schemeClr val="tx1"/>
           </a:solidFill>
@@ -2820,16 +2820,16 @@
           <a:cs typeface="+mn-cs"/>
         </a:defRPr>
       </a:lvl7pPr>
-      <a:lvl8pPr marL="1371600" indent="-91440" algn="l" defTabSz="365760" rtl="0" eaLnBrk="1" latinLnBrk="0" hangingPunct="1">
+      <a:lvl8pPr marL="1189177" indent="-79278" algn="l" defTabSz="317114" rtl="0" eaLnBrk="1" latinLnBrk="0" hangingPunct="1">
         <a:lnSpc>
           <a:spcPct val="90000"/>
         </a:lnSpc>
         <a:spcBef>
-          <a:spcPts val="200"/>
+          <a:spcPts val="173"/>
         </a:spcBef>
         <a:buFont typeface="Arial" panose="020B0604020202020204" pitchFamily="34" charset="0"/>
         <a:buChar char="•"/>
-        <a:defRPr sz="720" kern="1200">
+        <a:defRPr sz="624" kern="1200">
           <a:solidFill>
             <a:schemeClr val="tx1"/>
           </a:solidFill>
@@ -2838,16 +2838,16 @@
           <a:cs typeface="+mn-cs"/>
         </a:defRPr>
       </a:lvl8pPr>
-      <a:lvl9pPr marL="1554480" indent="-91440" algn="l" defTabSz="365760" rtl="0" eaLnBrk="1" latinLnBrk="0" hangingPunct="1">
+      <a:lvl9pPr marL="1347734" indent="-79278" algn="l" defTabSz="317114" rtl="0" eaLnBrk="1" latinLnBrk="0" hangingPunct="1">
         <a:lnSpc>
           <a:spcPct val="90000"/>
         </a:lnSpc>
         <a:spcBef>
-          <a:spcPts val="200"/>
+          <a:spcPts val="173"/>
         </a:spcBef>
         <a:buFont typeface="Arial" panose="020B0604020202020204" pitchFamily="34" charset="0"/>
         <a:buChar char="•"/>
-        <a:defRPr sz="720" kern="1200">
+        <a:defRPr sz="624" kern="1200">
           <a:solidFill>
             <a:schemeClr val="tx1"/>
           </a:solidFill>
@@ -2861,8 +2861,8 @@
       <a:defPPr>
         <a:defRPr lang="en-US"/>
       </a:defPPr>
-      <a:lvl1pPr marL="0" algn="l" defTabSz="365760" rtl="0" eaLnBrk="1" latinLnBrk="0" hangingPunct="1">
-        <a:defRPr sz="720" kern="1200">
+      <a:lvl1pPr marL="0" algn="l" defTabSz="317114" rtl="0" eaLnBrk="1" latinLnBrk="0" hangingPunct="1">
+        <a:defRPr sz="624" kern="1200">
           <a:solidFill>
             <a:schemeClr val="tx1"/>
           </a:solidFill>
@@ -2871,8 +2871,8 @@
           <a:cs typeface="+mn-cs"/>
         </a:defRPr>
       </a:lvl1pPr>
-      <a:lvl2pPr marL="182880" algn="l" defTabSz="365760" rtl="0" eaLnBrk="1" latinLnBrk="0" hangingPunct="1">
-        <a:defRPr sz="720" kern="1200">
+      <a:lvl2pPr marL="158557" algn="l" defTabSz="317114" rtl="0" eaLnBrk="1" latinLnBrk="0" hangingPunct="1">
+        <a:defRPr sz="624" kern="1200">
           <a:solidFill>
             <a:schemeClr val="tx1"/>
           </a:solidFill>
@@ -2881,8 +2881,8 @@
           <a:cs typeface="+mn-cs"/>
         </a:defRPr>
       </a:lvl2pPr>
-      <a:lvl3pPr marL="365760" algn="l" defTabSz="365760" rtl="0" eaLnBrk="1" latinLnBrk="0" hangingPunct="1">
-        <a:defRPr sz="720" kern="1200">
+      <a:lvl3pPr marL="317114" algn="l" defTabSz="317114" rtl="0" eaLnBrk="1" latinLnBrk="0" hangingPunct="1">
+        <a:defRPr sz="624" kern="1200">
           <a:solidFill>
             <a:schemeClr val="tx1"/>
           </a:solidFill>
@@ -2891,8 +2891,8 @@
           <a:cs typeface="+mn-cs"/>
         </a:defRPr>
       </a:lvl3pPr>
-      <a:lvl4pPr marL="548640" algn="l" defTabSz="365760" rtl="0" eaLnBrk="1" latinLnBrk="0" hangingPunct="1">
-        <a:defRPr sz="720" kern="1200">
+      <a:lvl4pPr marL="475671" algn="l" defTabSz="317114" rtl="0" eaLnBrk="1" latinLnBrk="0" hangingPunct="1">
+        <a:defRPr sz="624" kern="1200">
           <a:solidFill>
             <a:schemeClr val="tx1"/>
           </a:solidFill>
@@ -2901,8 +2901,8 @@
           <a:cs typeface="+mn-cs"/>
         </a:defRPr>
       </a:lvl4pPr>
-      <a:lvl5pPr marL="731520" algn="l" defTabSz="365760" rtl="0" eaLnBrk="1" latinLnBrk="0" hangingPunct="1">
-        <a:defRPr sz="720" kern="1200">
+      <a:lvl5pPr marL="634228" algn="l" defTabSz="317114" rtl="0" eaLnBrk="1" latinLnBrk="0" hangingPunct="1">
+        <a:defRPr sz="624" kern="1200">
           <a:solidFill>
             <a:schemeClr val="tx1"/>
           </a:solidFill>
@@ -2911,8 +2911,8 @@
           <a:cs typeface="+mn-cs"/>
         </a:defRPr>
       </a:lvl5pPr>
-      <a:lvl6pPr marL="914400" algn="l" defTabSz="365760" rtl="0" eaLnBrk="1" latinLnBrk="0" hangingPunct="1">
-        <a:defRPr sz="720" kern="1200">
+      <a:lvl6pPr marL="792785" algn="l" defTabSz="317114" rtl="0" eaLnBrk="1" latinLnBrk="0" hangingPunct="1">
+        <a:defRPr sz="624" kern="1200">
           <a:solidFill>
             <a:schemeClr val="tx1"/>
           </a:solidFill>
@@ -2921,8 +2921,8 @@
           <a:cs typeface="+mn-cs"/>
         </a:defRPr>
       </a:lvl6pPr>
-      <a:lvl7pPr marL="1097280" algn="l" defTabSz="365760" rtl="0" eaLnBrk="1" latinLnBrk="0" hangingPunct="1">
-        <a:defRPr sz="720" kern="1200">
+      <a:lvl7pPr marL="951342" algn="l" defTabSz="317114" rtl="0" eaLnBrk="1" latinLnBrk="0" hangingPunct="1">
+        <a:defRPr sz="624" kern="1200">
           <a:solidFill>
             <a:schemeClr val="tx1"/>
           </a:solidFill>
@@ -2931,8 +2931,8 @@
           <a:cs typeface="+mn-cs"/>
         </a:defRPr>
       </a:lvl7pPr>
-      <a:lvl8pPr marL="1280160" algn="l" defTabSz="365760" rtl="0" eaLnBrk="1" latinLnBrk="0" hangingPunct="1">
-        <a:defRPr sz="720" kern="1200">
+      <a:lvl8pPr marL="1109899" algn="l" defTabSz="317114" rtl="0" eaLnBrk="1" latinLnBrk="0" hangingPunct="1">
+        <a:defRPr sz="624" kern="1200">
           <a:solidFill>
             <a:schemeClr val="tx1"/>
           </a:solidFill>
@@ -2941,8 +2941,8 @@
           <a:cs typeface="+mn-cs"/>
         </a:defRPr>
       </a:lvl8pPr>
-      <a:lvl9pPr marL="1463040" algn="l" defTabSz="365760" rtl="0" eaLnBrk="1" latinLnBrk="0" hangingPunct="1">
-        <a:defRPr sz="720" kern="1200">
+      <a:lvl9pPr marL="1268456" algn="l" defTabSz="317114" rtl="0" eaLnBrk="1" latinLnBrk="0" hangingPunct="1">
+        <a:defRPr sz="624" kern="1200">
           <a:solidFill>
             <a:schemeClr val="tx1"/>
           </a:solidFill>
@@ -2987,7 +2987,7 @@
         </p:nvSpPr>
         <p:spPr>
           <a:xfrm>
-            <a:off x="404376" y="2026"/>
+            <a:off x="404379" y="-1739"/>
             <a:ext cx="2246919" cy="153888"/>
           </a:xfrm>
           <a:prstGeom prst="rect">
@@ -3025,7 +3025,7 @@
         </p:nvSpPr>
         <p:spPr>
           <a:xfrm>
-            <a:off x="4591271" y="2026"/>
+            <a:off x="4591274" y="-1739"/>
             <a:ext cx="2246919" cy="153888"/>
           </a:xfrm>
           <a:prstGeom prst="rect">
@@ -3064,7 +3064,7 @@
         </p:nvSpPr>
         <p:spPr>
           <a:xfrm>
-            <a:off x="5181" y="503459"/>
+            <a:off x="5184" y="443996"/>
             <a:ext cx="355867" cy="153888"/>
           </a:xfrm>
           <a:prstGeom prst="rect">
@@ -3102,7 +3102,7 @@
         </p:nvSpPr>
         <p:spPr>
           <a:xfrm>
-            <a:off x="5181" y="1277154"/>
+            <a:off x="1173" y="1117215"/>
             <a:ext cx="363882" cy="153888"/>
           </a:xfrm>
           <a:prstGeom prst="rect">
@@ -3140,7 +3140,7 @@
         </p:nvSpPr>
         <p:spPr>
           <a:xfrm>
-            <a:off x="5181" y="2255616"/>
+            <a:off x="5184" y="1940753"/>
             <a:ext cx="343043" cy="153888"/>
           </a:xfrm>
           <a:prstGeom prst="rect">
@@ -3178,7 +3178,7 @@
         </p:nvSpPr>
         <p:spPr>
           <a:xfrm>
-            <a:off x="529228" y="694637"/>
+            <a:off x="529228" y="635177"/>
             <a:ext cx="57708" cy="123111"/>
           </a:xfrm>
           <a:prstGeom prst="rect">
@@ -3217,7 +3217,7 @@
         </p:nvSpPr>
         <p:spPr>
           <a:xfrm>
-            <a:off x="1470036" y="318598"/>
+            <a:off x="1470036" y="259138"/>
             <a:ext cx="269304" cy="123111"/>
           </a:xfrm>
           <a:prstGeom prst="rect">
@@ -3256,7 +3256,7 @@
         </p:nvSpPr>
         <p:spPr>
           <a:xfrm>
-            <a:off x="4086485" y="310799"/>
+            <a:off x="4086488" y="251339"/>
             <a:ext cx="757137" cy="117725"/>
           </a:xfrm>
           <a:prstGeom prst="rect">
@@ -3295,7 +3295,7 @@
         </p:nvGrpSpPr>
         <p:grpSpPr>
           <a:xfrm>
-            <a:off x="1867290" y="1266589"/>
+            <a:off x="1867293" y="1079426"/>
             <a:ext cx="4202727" cy="230416"/>
             <a:chOff x="1867290" y="1238052"/>
             <a:chExt cx="4202727" cy="230416"/>
@@ -3880,7 +3880,7 @@
         </p:nvSpPr>
         <p:spPr>
           <a:xfrm>
-            <a:off x="2988993" y="2457783"/>
+            <a:off x="2988993" y="2142923"/>
             <a:ext cx="54502" cy="117725"/>
           </a:xfrm>
           <a:prstGeom prst="rect">
@@ -3919,7 +3919,7 @@
         </p:nvSpPr>
         <p:spPr>
           <a:xfrm>
-            <a:off x="1963271" y="1893269"/>
+            <a:off x="1963271" y="1578409"/>
             <a:ext cx="566982" cy="117725"/>
           </a:xfrm>
           <a:prstGeom prst="rect">
@@ -3958,7 +3958,7 @@
         </p:nvSpPr>
         <p:spPr>
           <a:xfrm>
-            <a:off x="1461542" y="2085077"/>
+            <a:off x="1461545" y="1770217"/>
             <a:ext cx="371897" cy="117725"/>
           </a:xfrm>
           <a:prstGeom prst="rect">
@@ -3997,7 +3997,7 @@
         </p:nvGrpSpPr>
         <p:grpSpPr>
           <a:xfrm>
-            <a:off x="1463417" y="2218261"/>
+            <a:off x="1463417" y="1903398"/>
             <a:ext cx="5001234" cy="228600"/>
             <a:chOff x="1463417" y="2218261"/>
             <a:chExt cx="5001234" cy="228600"/>
@@ -4517,7 +4517,7 @@
             <a:lstStyle/>
             <a:p>
               <a:pPr algn="ctr"/>
-              <a:endParaRPr lang="en-US" sz="2293"/>
+              <a:endParaRPr lang="en-US" sz="2293" dirty="0"/>
             </a:p>
           </p:txBody>
         </p:sp>
@@ -5126,7 +5126,7 @@
         </p:nvSpPr>
         <p:spPr>
           <a:xfrm>
-            <a:off x="336066" y="318598"/>
+            <a:off x="336066" y="259138"/>
             <a:ext cx="444032" cy="123111"/>
           </a:xfrm>
           <a:prstGeom prst="rect">
@@ -5165,7 +5165,7 @@
         </p:nvSpPr>
         <p:spPr>
           <a:xfrm>
-            <a:off x="1518126" y="694637"/>
+            <a:off x="1518126" y="635177"/>
             <a:ext cx="173124" cy="123111"/>
           </a:xfrm>
           <a:prstGeom prst="rect">
@@ -5204,7 +5204,7 @@
         </p:nvSpPr>
         <p:spPr>
           <a:xfrm>
-            <a:off x="2622441" y="694637"/>
+            <a:off x="2622441" y="635177"/>
             <a:ext cx="57708" cy="123111"/>
           </a:xfrm>
           <a:prstGeom prst="rect">
@@ -5243,7 +5243,7 @@
         </p:nvSpPr>
         <p:spPr>
           <a:xfrm>
-            <a:off x="2842646" y="694637"/>
+            <a:off x="2842646" y="635177"/>
             <a:ext cx="57708" cy="123111"/>
           </a:xfrm>
           <a:prstGeom prst="rect">
@@ -5282,7 +5282,7 @@
         </p:nvSpPr>
         <p:spPr>
           <a:xfrm>
-            <a:off x="2978920" y="694637"/>
+            <a:off x="2978920" y="635177"/>
             <a:ext cx="57708" cy="123111"/>
           </a:xfrm>
           <a:prstGeom prst="rect">
@@ -5321,7 +5321,7 @@
         </p:nvSpPr>
         <p:spPr>
           <a:xfrm>
-            <a:off x="3150255" y="694637"/>
+            <a:off x="3150255" y="635177"/>
             <a:ext cx="144270" cy="123111"/>
           </a:xfrm>
           <a:prstGeom prst="rect">
@@ -5360,7 +5360,7 @@
         </p:nvSpPr>
         <p:spPr>
           <a:xfrm>
-            <a:off x="2416758" y="318598"/>
+            <a:off x="2416758" y="135181"/>
             <a:ext cx="444032" cy="123111"/>
           </a:xfrm>
           <a:prstGeom prst="rect">
@@ -5399,7 +5399,7 @@
         </p:nvSpPr>
         <p:spPr>
           <a:xfrm>
-            <a:off x="1821289" y="1128261"/>
+            <a:off x="1821289" y="941101"/>
             <a:ext cx="320602" cy="117725"/>
           </a:xfrm>
           <a:prstGeom prst="rect">
@@ -5438,7 +5438,7 @@
         </p:nvSpPr>
         <p:spPr>
           <a:xfrm>
-            <a:off x="2242347" y="1128261"/>
+            <a:off x="2242347" y="941101"/>
             <a:ext cx="540212" cy="117725"/>
           </a:xfrm>
           <a:prstGeom prst="rect">
@@ -5477,7 +5477,7 @@
         </p:nvSpPr>
         <p:spPr>
           <a:xfrm>
-            <a:off x="2883011" y="1128261"/>
+            <a:off x="2883011" y="941101"/>
             <a:ext cx="320602" cy="117725"/>
           </a:xfrm>
           <a:prstGeom prst="rect">
@@ -5516,7 +5516,7 @@
         </p:nvSpPr>
         <p:spPr>
           <a:xfrm>
-            <a:off x="4070371" y="1137143"/>
+            <a:off x="4070371" y="949983"/>
             <a:ext cx="320602" cy="117725"/>
           </a:xfrm>
           <a:prstGeom prst="rect">
@@ -5555,7 +5555,7 @@
         </p:nvSpPr>
         <p:spPr>
           <a:xfrm>
-            <a:off x="4809400" y="1139019"/>
+            <a:off x="4809400" y="951859"/>
             <a:ext cx="540212" cy="117725"/>
           </a:xfrm>
           <a:prstGeom prst="rect">
@@ -5594,7 +5594,7 @@
         </p:nvSpPr>
         <p:spPr>
           <a:xfrm>
-            <a:off x="5794208" y="1139019"/>
+            <a:off x="5794208" y="951859"/>
             <a:ext cx="320602" cy="117725"/>
           </a:xfrm>
           <a:prstGeom prst="rect">
@@ -5633,7 +5633,7 @@
         </p:nvGrpSpPr>
         <p:grpSpPr>
           <a:xfrm>
-            <a:off x="1905842" y="1505179"/>
+            <a:off x="1905845" y="1318019"/>
             <a:ext cx="4116795" cy="117725"/>
             <a:chOff x="1905842" y="1475854"/>
             <a:chExt cx="4116795" cy="117725"/>
@@ -5974,7 +5974,7 @@
         </p:nvSpPr>
         <p:spPr>
           <a:xfrm>
-            <a:off x="1621470" y="2457783"/>
+            <a:off x="1621470" y="2142923"/>
             <a:ext cx="54502" cy="117725"/>
           </a:xfrm>
           <a:prstGeom prst="rect">
@@ -6013,7 +6013,7 @@
         </p:nvSpPr>
         <p:spPr>
           <a:xfrm>
-            <a:off x="1967106" y="2457783"/>
+            <a:off x="1967109" y="2142923"/>
             <a:ext cx="109005" cy="117725"/>
           </a:xfrm>
           <a:prstGeom prst="rect">
@@ -6052,7 +6052,7 @@
         </p:nvSpPr>
         <p:spPr>
           <a:xfrm>
-            <a:off x="2282825" y="2457783"/>
+            <a:off x="2282825" y="2142923"/>
             <a:ext cx="136256" cy="117725"/>
           </a:xfrm>
           <a:prstGeom prst="rect">
@@ -6091,7 +6091,7 @@
         </p:nvSpPr>
         <p:spPr>
           <a:xfrm>
-            <a:off x="2642529" y="2457783"/>
+            <a:off x="2642532" y="2142923"/>
             <a:ext cx="109005" cy="117725"/>
           </a:xfrm>
           <a:prstGeom prst="rect">
@@ -6130,7 +6130,7 @@
         </p:nvSpPr>
         <p:spPr>
           <a:xfrm>
-            <a:off x="4521749" y="2457783"/>
+            <a:off x="4521752" y="2142923"/>
             <a:ext cx="109005" cy="117725"/>
           </a:xfrm>
           <a:prstGeom prst="rect">
@@ -6169,7 +6169,7 @@
         </p:nvSpPr>
         <p:spPr>
           <a:xfrm>
-            <a:off x="5188009" y="2457783"/>
+            <a:off x="5188012" y="2142923"/>
             <a:ext cx="109005" cy="117725"/>
           </a:xfrm>
           <a:prstGeom prst="rect">
@@ -6208,7 +6208,7 @@
         </p:nvSpPr>
         <p:spPr>
           <a:xfrm>
-            <a:off x="5854269" y="2457782"/>
+            <a:off x="5854272" y="2142922"/>
             <a:ext cx="109005" cy="117725"/>
           </a:xfrm>
           <a:prstGeom prst="rect">
@@ -6247,7 +6247,7 @@
         </p:nvSpPr>
         <p:spPr>
           <a:xfrm>
-            <a:off x="4842495" y="2457783"/>
+            <a:off x="4842495" y="2142923"/>
             <a:ext cx="136256" cy="117725"/>
           </a:xfrm>
           <a:prstGeom prst="rect">
@@ -6286,7 +6286,7 @@
         </p:nvSpPr>
         <p:spPr>
           <a:xfrm>
-            <a:off x="5512448" y="2457783"/>
+            <a:off x="5512448" y="2142923"/>
             <a:ext cx="136256" cy="117725"/>
           </a:xfrm>
           <a:prstGeom prst="rect">
@@ -6325,7 +6325,7 @@
         </p:nvGrpSpPr>
         <p:grpSpPr>
           <a:xfrm>
-            <a:off x="415788" y="454266"/>
+            <a:off x="415788" y="394806"/>
             <a:ext cx="6430510" cy="229505"/>
             <a:chOff x="415788" y="454266"/>
             <a:chExt cx="6430510" cy="229505"/>
@@ -7240,7 +7240,7 @@
         </p:nvSpPr>
         <p:spPr>
           <a:xfrm>
-            <a:off x="3073521" y="694637"/>
+            <a:off x="3073521" y="635177"/>
             <a:ext cx="57708" cy="123111"/>
           </a:xfrm>
           <a:prstGeom prst="rect">
@@ -7279,7 +7279,7 @@
         </p:nvSpPr>
         <p:spPr>
           <a:xfrm>
-            <a:off x="2740073" y="1893269"/>
+            <a:off x="2740076" y="1578409"/>
             <a:ext cx="238847" cy="117725"/>
           </a:xfrm>
           <a:prstGeom prst="rect">
@@ -7318,7 +7318,7 @@
         </p:nvSpPr>
         <p:spPr>
           <a:xfrm>
-            <a:off x="3120105" y="1893269"/>
+            <a:off x="3120108" y="1578409"/>
             <a:ext cx="317395" cy="117725"/>
           </a:xfrm>
           <a:prstGeom prst="rect">
@@ -7357,7 +7357,7 @@
         </p:nvSpPr>
         <p:spPr>
           <a:xfrm>
-            <a:off x="3054145" y="191113"/>
+            <a:off x="3054145" y="131652"/>
             <a:ext cx="269304" cy="123111"/>
           </a:xfrm>
           <a:prstGeom prst="rect">
@@ -7396,7 +7396,7 @@
         </p:nvSpPr>
         <p:spPr>
           <a:xfrm>
-            <a:off x="3411793" y="191113"/>
+            <a:off x="3411793" y="131652"/>
             <a:ext cx="126638" cy="123111"/>
           </a:xfrm>
           <a:prstGeom prst="rect">
@@ -7435,7 +7435,7 @@
         </p:nvSpPr>
         <p:spPr>
           <a:xfrm>
-            <a:off x="3626775" y="191113"/>
+            <a:off x="3626775" y="131652"/>
             <a:ext cx="96180" cy="123111"/>
           </a:xfrm>
           <a:prstGeom prst="rect">
@@ -7474,7 +7474,7 @@
         </p:nvSpPr>
         <p:spPr>
           <a:xfrm>
-            <a:off x="4972406" y="1893269"/>
+            <a:off x="4972406" y="1578409"/>
             <a:ext cx="540212" cy="117725"/>
           </a:xfrm>
           <a:prstGeom prst="rect">
@@ -7516,7 +7516,7 @@
         </p:nvCxnSpPr>
         <p:spPr>
           <a:xfrm flipH="1">
-            <a:off x="2870250" y="314224"/>
+            <a:off x="2870253" y="254764"/>
             <a:ext cx="318547" cy="140947"/>
           </a:xfrm>
           <a:prstGeom prst="line">
@@ -7558,14 +7558,14 @@
           <p:cNvCxnSpPr>
             <a:cxnSpLocks/>
             <a:stCxn id="146" idx="2"/>
-            <a:endCxn id="8" idx="0"/>
+            <a:endCxn id="134" idx="0"/>
           </p:cNvCxnSpPr>
           <p:nvPr/>
         </p:nvCxnSpPr>
         <p:spPr>
           <a:xfrm flipH="1">
-            <a:off x="3007774" y="314224"/>
-            <a:ext cx="467338" cy="140947"/>
+            <a:off x="3099906" y="254764"/>
+            <a:ext cx="375206" cy="140947"/>
           </a:xfrm>
           <a:prstGeom prst="line">
             <a:avLst/>
@@ -7612,7 +7612,7 @@
         </p:nvCxnSpPr>
         <p:spPr>
           <a:xfrm flipH="1">
-            <a:off x="3160502" y="314224"/>
+            <a:off x="3160505" y="254764"/>
             <a:ext cx="514363" cy="140947"/>
           </a:xfrm>
           <a:prstGeom prst="line">
@@ -7656,7 +7656,7 @@
         </p:nvSpPr>
         <p:spPr>
           <a:xfrm>
-            <a:off x="3588902" y="1014032"/>
+            <a:off x="3588902" y="826872"/>
             <a:ext cx="96180" cy="123111"/>
           </a:xfrm>
           <a:prstGeom prst="rect">
@@ -7699,7 +7699,7 @@
         </p:nvCxnSpPr>
         <p:spPr>
           <a:xfrm flipH="1">
-            <a:off x="3160666" y="1137143"/>
+            <a:off x="3160666" y="949980"/>
             <a:ext cx="476326" cy="131256"/>
           </a:xfrm>
           <a:prstGeom prst="line">
@@ -7747,7 +7747,7 @@
         </p:nvCxnSpPr>
         <p:spPr>
           <a:xfrm>
-            <a:off x="3636992" y="1137143"/>
+            <a:off x="3636992" y="949983"/>
             <a:ext cx="465638" cy="129447"/>
           </a:xfrm>
           <a:prstGeom prst="line">
@@ -7793,7 +7793,7 @@
         </p:nvCxnSpPr>
         <p:spPr>
           <a:xfrm flipH="1" flipV="1">
-            <a:off x="2522220" y="2004060"/>
+            <a:off x="2522223" y="1689200"/>
             <a:ext cx="174321" cy="214201"/>
           </a:xfrm>
           <a:prstGeom prst="line">
@@ -7840,7 +7840,7 @@
         </p:nvCxnSpPr>
         <p:spPr>
           <a:xfrm flipH="1">
-            <a:off x="2019740" y="2013585"/>
+            <a:off x="2019743" y="1698722"/>
             <a:ext cx="35755" cy="204676"/>
           </a:xfrm>
           <a:prstGeom prst="line">
@@ -7884,7 +7884,7 @@
         </p:nvSpPr>
         <p:spPr>
           <a:xfrm>
-            <a:off x="2216640" y="2085077"/>
+            <a:off x="2216640" y="1770217"/>
             <a:ext cx="290144" cy="117725"/>
           </a:xfrm>
           <a:prstGeom prst="rect">
@@ -7923,7 +7923,7 @@
         </p:nvSpPr>
         <p:spPr>
           <a:xfrm>
-            <a:off x="3578685" y="1890576"/>
+            <a:off x="3578685" y="1575716"/>
             <a:ext cx="96180" cy="123111"/>
           </a:xfrm>
           <a:prstGeom prst="rect">
@@ -7962,7 +7962,7 @@
         </p:nvSpPr>
         <p:spPr>
           <a:xfrm>
-            <a:off x="4765551" y="2085077"/>
+            <a:off x="4765551" y="1770217"/>
             <a:ext cx="290144" cy="117725"/>
           </a:xfrm>
           <a:prstGeom prst="rect">
@@ -8001,7 +8001,7 @@
         </p:nvSpPr>
         <p:spPr>
           <a:xfrm>
-            <a:off x="5435504" y="2085077"/>
+            <a:off x="5435504" y="1770217"/>
             <a:ext cx="290144" cy="117725"/>
           </a:xfrm>
           <a:prstGeom prst="rect">
@@ -8040,7 +8040,7 @@
         </p:nvSpPr>
         <p:spPr>
           <a:xfrm>
-            <a:off x="6098891" y="2085077"/>
+            <a:off x="6098894" y="1770217"/>
             <a:ext cx="371897" cy="117725"/>
           </a:xfrm>
           <a:prstGeom prst="rect">
@@ -8079,7 +8079,7 @@
         </p:nvSpPr>
         <p:spPr>
           <a:xfrm>
-            <a:off x="3865108" y="1893269"/>
+            <a:off x="3865111" y="1578409"/>
             <a:ext cx="317395" cy="117725"/>
           </a:xfrm>
           <a:prstGeom prst="rect">
@@ -8118,7 +8118,7 @@
         </p:nvSpPr>
         <p:spPr>
           <a:xfrm>
-            <a:off x="4372746" y="1893269"/>
+            <a:off x="4372749" y="1578409"/>
             <a:ext cx="238847" cy="117725"/>
           </a:xfrm>
           <a:prstGeom prst="rect">
@@ -8161,7 +8161,7 @@
         </p:nvCxnSpPr>
         <p:spPr>
           <a:xfrm flipV="1">
-            <a:off x="5242512" y="2010994"/>
+            <a:off x="5242512" y="1696134"/>
             <a:ext cx="0" cy="207267"/>
           </a:xfrm>
           <a:prstGeom prst="line">
@@ -8208,7 +8208,7 @@
         </p:nvCxnSpPr>
         <p:spPr>
           <a:xfrm flipV="1">
-            <a:off x="4576252" y="2002155"/>
+            <a:off x="4576252" y="1687292"/>
             <a:ext cx="376748" cy="216106"/>
           </a:xfrm>
           <a:prstGeom prst="line">
@@ -8254,7 +8254,7 @@
         </p:nvCxnSpPr>
         <p:spPr>
           <a:xfrm flipH="1" flipV="1">
-            <a:off x="5520690" y="2005965"/>
+            <a:off x="5520690" y="1691102"/>
             <a:ext cx="388082" cy="207214"/>
           </a:xfrm>
           <a:prstGeom prst="line">
@@ -8302,7 +8302,7 @@
         </p:nvCxnSpPr>
         <p:spPr>
           <a:xfrm flipH="1" flipV="1">
-            <a:off x="2859497" y="2010994"/>
+            <a:off x="2859500" y="1696134"/>
             <a:ext cx="43553" cy="207267"/>
           </a:xfrm>
           <a:prstGeom prst="line">
@@ -8350,7 +8350,7 @@
         </p:nvCxnSpPr>
         <p:spPr>
           <a:xfrm flipV="1">
-            <a:off x="3016070" y="2010994"/>
+            <a:off x="3016073" y="1696134"/>
             <a:ext cx="262733" cy="207267"/>
           </a:xfrm>
           <a:prstGeom prst="line">
@@ -8397,7 +8397,7 @@
         </p:nvCxnSpPr>
         <p:spPr>
           <a:xfrm flipH="1" flipV="1">
-            <a:off x="2990850" y="2005965"/>
+            <a:off x="2990850" y="1691102"/>
             <a:ext cx="135690" cy="212296"/>
           </a:xfrm>
           <a:prstGeom prst="line">
@@ -8445,7 +8445,7 @@
         </p:nvCxnSpPr>
         <p:spPr>
           <a:xfrm flipV="1">
-            <a:off x="3164428" y="2013687"/>
+            <a:off x="3164431" y="1698824"/>
             <a:ext cx="462347" cy="204574"/>
           </a:xfrm>
           <a:prstGeom prst="line">
@@ -8493,7 +8493,7 @@
         </p:nvCxnSpPr>
         <p:spPr>
           <a:xfrm flipH="1" flipV="1">
-            <a:off x="3626775" y="2013687"/>
+            <a:off x="3626778" y="1698824"/>
             <a:ext cx="473427" cy="204574"/>
           </a:xfrm>
           <a:prstGeom prst="line">
@@ -8541,7 +8541,7 @@
         </p:nvCxnSpPr>
         <p:spPr>
           <a:xfrm flipH="1" flipV="1">
-            <a:off x="4023806" y="2010994"/>
+            <a:off x="4023809" y="1696134"/>
             <a:ext cx="227961" cy="207267"/>
           </a:xfrm>
           <a:prstGeom prst="line">
@@ -8588,7 +8588,7 @@
         </p:nvCxnSpPr>
         <p:spPr>
           <a:xfrm flipV="1">
-            <a:off x="4137569" y="2011680"/>
+            <a:off x="4137572" y="1696820"/>
             <a:ext cx="221071" cy="206581"/>
           </a:xfrm>
           <a:prstGeom prst="line">
@@ -8636,7 +8636,7 @@
         </p:nvCxnSpPr>
         <p:spPr>
           <a:xfrm flipV="1">
-            <a:off x="4365813" y="2010994"/>
+            <a:off x="4365816" y="1696134"/>
             <a:ext cx="126357" cy="207267"/>
           </a:xfrm>
           <a:prstGeom prst="line">
@@ -8680,7 +8680,7 @@
         </p:nvSpPr>
         <p:spPr>
           <a:xfrm>
-            <a:off x="4221837" y="2457782"/>
+            <a:off x="4221837" y="2142922"/>
             <a:ext cx="54502" cy="117725"/>
           </a:xfrm>
           <a:prstGeom prst="rect">
@@ -8719,7 +8719,7 @@
         </p:nvSpPr>
         <p:spPr>
           <a:xfrm>
-            <a:off x="3254675" y="2591212"/>
+            <a:off x="3254675" y="2276352"/>
             <a:ext cx="136256" cy="117725"/>
           </a:xfrm>
           <a:prstGeom prst="rect">
@@ -8758,7 +8758,7 @@
         </p:nvSpPr>
         <p:spPr>
           <a:xfrm>
-            <a:off x="2990567" y="2591212"/>
+            <a:off x="2990567" y="2276352"/>
             <a:ext cx="136256" cy="117725"/>
           </a:xfrm>
           <a:prstGeom prst="rect">
@@ -8800,7 +8800,7 @@
         </p:nvCxnSpPr>
         <p:spPr>
           <a:xfrm flipH="1" flipV="1">
-            <a:off x="2903050" y="2446861"/>
+            <a:off x="2903050" y="2132001"/>
             <a:ext cx="80180" cy="151559"/>
           </a:xfrm>
           <a:prstGeom prst="line">
@@ -8847,7 +8847,7 @@
         </p:nvCxnSpPr>
         <p:spPr>
           <a:xfrm flipV="1">
-            <a:off x="3091815" y="2446861"/>
+            <a:off x="3091818" y="2132001"/>
             <a:ext cx="34725" cy="147749"/>
           </a:xfrm>
           <a:prstGeom prst="line">
@@ -8895,7 +8895,7 @@
         </p:nvCxnSpPr>
         <p:spPr>
           <a:xfrm flipH="1" flipV="1">
-            <a:off x="3164428" y="2446861"/>
+            <a:off x="3164431" y="2132001"/>
             <a:ext cx="158375" cy="144351"/>
           </a:xfrm>
           <a:prstGeom prst="line">
@@ -8939,7 +8939,7 @@
         </p:nvSpPr>
         <p:spPr>
           <a:xfrm>
-            <a:off x="4143846" y="2590532"/>
+            <a:off x="4143846" y="2275672"/>
             <a:ext cx="136256" cy="117725"/>
           </a:xfrm>
           <a:prstGeom prst="rect">
@@ -8978,7 +8978,7 @@
         </p:nvSpPr>
         <p:spPr>
           <a:xfrm>
-            <a:off x="3879738" y="2590532"/>
+            <a:off x="3879738" y="2275672"/>
             <a:ext cx="136256" cy="117725"/>
           </a:xfrm>
           <a:prstGeom prst="rect">
@@ -9020,7 +9020,7 @@
         </p:nvCxnSpPr>
         <p:spPr>
           <a:xfrm flipV="1">
-            <a:off x="4282440" y="2446861"/>
+            <a:off x="4282443" y="2132001"/>
             <a:ext cx="83373" cy="151559"/>
           </a:xfrm>
           <a:prstGeom prst="line">
@@ -9067,7 +9067,7 @@
         </p:nvCxnSpPr>
         <p:spPr>
           <a:xfrm flipH="1" flipV="1">
-            <a:off x="4137569" y="2446861"/>
+            <a:off x="4137572" y="2132001"/>
             <a:ext cx="45811" cy="151559"/>
           </a:xfrm>
           <a:prstGeom prst="line">
@@ -9115,7 +9115,7 @@
         </p:nvCxnSpPr>
         <p:spPr>
           <a:xfrm flipV="1">
-            <a:off x="3947866" y="2446861"/>
+            <a:off x="3947866" y="2132001"/>
             <a:ext cx="152336" cy="143671"/>
           </a:xfrm>
           <a:prstGeom prst="line">
@@ -9159,7 +9159,7 @@
         </p:nvSpPr>
         <p:spPr>
           <a:xfrm>
-            <a:off x="6257588" y="2457782"/>
+            <a:off x="6257588" y="2142922"/>
             <a:ext cx="54502" cy="117725"/>
           </a:xfrm>
           <a:prstGeom prst="rect">
@@ -9184,6 +9184,101 @@
           </a:p>
         </p:txBody>
       </p:sp>
+      <p:cxnSp>
+        <p:nvCxnSpPr>
+          <p:cNvPr id="11" name="Straight Connector 10">
+            <a:extLst>
+              <a:ext uri="{FF2B5EF4-FFF2-40B4-BE49-F238E27FC236}">
+                <a16:creationId xmlns:a16="http://schemas.microsoft.com/office/drawing/2014/main" id="{40637F0F-1218-FB98-355D-03CECE2049F1}"/>
+              </a:ext>
+            </a:extLst>
+          </p:cNvPr>
+          <p:cNvCxnSpPr>
+            <a:cxnSpLocks/>
+            <a:endCxn id="8" idx="0"/>
+          </p:cNvCxnSpPr>
+          <p:nvPr/>
+        </p:nvCxnSpPr>
+        <p:spPr>
+          <a:xfrm>
+            <a:off x="2739574" y="259854"/>
+            <a:ext cx="268203" cy="135857"/>
+          </a:xfrm>
+          <a:prstGeom prst="line">
+            <a:avLst/>
+          </a:prstGeom>
+          <a:ln w="3175" cap="rnd">
+            <a:solidFill>
+              <a:schemeClr val="tx1"/>
+            </a:solidFill>
+            <a:bevel/>
+            <a:headEnd type="none" w="med" len="sm"/>
+            <a:tailEnd type="none" w="med" len="med"/>
+          </a:ln>
+        </p:spPr>
+        <p:style>
+          <a:lnRef idx="2">
+            <a:schemeClr val="accent1"/>
+          </a:lnRef>
+          <a:fillRef idx="0">
+            <a:schemeClr val="accent1"/>
+          </a:fillRef>
+          <a:effectRef idx="1">
+            <a:schemeClr val="accent1"/>
+          </a:effectRef>
+          <a:fontRef idx="minor">
+            <a:schemeClr val="tx1"/>
+          </a:fontRef>
+        </p:style>
+      </p:cxnSp>
+      <p:cxnSp>
+        <p:nvCxnSpPr>
+          <p:cNvPr id="21" name="Straight Connector 20">
+            <a:extLst>
+              <a:ext uri="{FF2B5EF4-FFF2-40B4-BE49-F238E27FC236}">
+                <a16:creationId xmlns:a16="http://schemas.microsoft.com/office/drawing/2014/main" id="{C93EB0B5-528F-1CDF-C1CA-B644D6E6CF58}"/>
+              </a:ext>
+            </a:extLst>
+          </p:cNvPr>
+          <p:cNvCxnSpPr>
+            <a:cxnSpLocks/>
+            <a:stCxn id="37" idx="2"/>
+            <a:endCxn id="6" idx="0"/>
+          </p:cNvCxnSpPr>
+          <p:nvPr/>
+        </p:nvCxnSpPr>
+        <p:spPr>
+          <a:xfrm>
+            <a:off x="2638777" y="258290"/>
+            <a:ext cx="12521" cy="137418"/>
+          </a:xfrm>
+          <a:prstGeom prst="line">
+            <a:avLst/>
+          </a:prstGeom>
+          <a:ln w="3175" cap="rnd">
+            <a:solidFill>
+              <a:schemeClr val="tx1"/>
+            </a:solidFill>
+            <a:bevel/>
+            <a:headEnd type="none" w="med" len="sm"/>
+            <a:tailEnd type="none" w="med" len="med"/>
+          </a:ln>
+        </p:spPr>
+        <p:style>
+          <a:lnRef idx="2">
+            <a:schemeClr val="accent1"/>
+          </a:lnRef>
+          <a:fillRef idx="0">
+            <a:schemeClr val="accent1"/>
+          </a:fillRef>
+          <a:effectRef idx="1">
+            <a:schemeClr val="accent1"/>
+          </a:effectRef>
+          <a:fontRef idx="minor">
+            <a:schemeClr val="tx1"/>
+          </a:fontRef>
+        </p:style>
+      </p:cxnSp>
     </p:spTree>
     <p:extLst>
       <p:ext uri="{BB962C8B-B14F-4D97-AF65-F5344CB8AC3E}">

</xml_diff>